<commit_message>
System Design 101 (vi): sd-11-035 verification counts and per-document links; sd-11-036 Cloud Foundry source split
Co-Authored-By: Claude Sonnet 5.5 <noreply@anthropic.com>
Claude-Session: https://claude.ai/code/session_01MF1cUkoXgxEMeDan8VPPYR
</commit_message>
<xml_diff>
--- a/system-design-101/vi/lessons/sd-11-035/slides/sd-11-035.pptx
+++ b/system-design-101/vi/lessons/sd-11-035/slides/sd-11-035.pptx
@@ -13188,62 +13188,62 @@
               <a:buNone/>
             </a:pPr>
             <a:r>
+              <a:rPr lang="en-US" sz="3000" b="1" dirty="0" spc="-8" kern="0">
+                <a:solidFill>
+                  <a:srgbClr val="14161C"/>
+                </a:solidFill>
+                <a:latin typeface="Be Vietnam Pro" pitchFamily="34" charset="0"/>
+                <a:ea typeface="Be Vietnam Pro" pitchFamily="34" charset="-122"/>
+                <a:cs typeface="Be Vietnam Pro" pitchFamily="34" charset="-120"/>
+              </a:rPr>
+              <a:t>Bốn</a:t>
+            </a:r>
+            <a:r>
+              <a:rPr lang="en-US" sz="3000" b="1" dirty="0" spc="-5" kern="0">
+                <a:solidFill>
+                  <a:srgbClr val="14161C"/>
+                </a:solidFill>
+                <a:latin typeface="Be Vietnam Pro" pitchFamily="34" charset="0"/>
+                <a:ea typeface="Be Vietnam Pro" pitchFamily="34" charset="-122"/>
+                <a:cs typeface="Be Vietnam Pro" pitchFamily="34" charset="-120"/>
+              </a:rPr>
+              <a:t> khoản</a:t>
+            </a:r>
+            <a:r>
+              <a:rPr lang="en-US" sz="3000" b="1" dirty="0" spc="7" kern="0">
+                <a:solidFill>
+                  <a:srgbClr val="14161C"/>
+                </a:solidFill>
+                <a:latin typeface="Be Vietnam Pro" pitchFamily="34" charset="0"/>
+                <a:ea typeface="Be Vietnam Pro" pitchFamily="34" charset="-122"/>
+                <a:cs typeface="Be Vietnam Pro" pitchFamily="34" charset="-120"/>
+              </a:rPr>
+              <a:t> đối</a:t>
+            </a:r>
+            <a:r>
+              <a:rPr lang="en-US" sz="3000" b="1" dirty="0" spc="1" kern="0">
+                <a:solidFill>
+                  <a:srgbClr val="14161C"/>
+                </a:solidFill>
+                <a:latin typeface="Be Vietnam Pro" pitchFamily="34" charset="0"/>
+                <a:ea typeface="Be Vietnam Pro" pitchFamily="34" charset="-122"/>
+                <a:cs typeface="Be Vietnam Pro" pitchFamily="34" charset="-120"/>
+              </a:rPr>
+              <a:t> chiếu</a:t>
+            </a:r>
+            <a:r>
+              <a:rPr lang="en-US" sz="3000" b="1" dirty="0" spc="-13" kern="0">
+                <a:solidFill>
+                  <a:srgbClr val="14161C"/>
+                </a:solidFill>
+                <a:latin typeface="Be Vietnam Pro" pitchFamily="34" charset="0"/>
+                <a:ea typeface="Be Vietnam Pro" pitchFamily="34" charset="-122"/>
+                <a:cs typeface="Be Vietnam Pro" pitchFamily="34" charset="-120"/>
+              </a:rPr>
+              <a:t> với</a:t>
+            </a:r>
+            <a:r>
               <a:rPr lang="en-US" sz="3000" b="1" dirty="0" spc="-3" kern="0">
-                <a:solidFill>
-                  <a:srgbClr val="14161C"/>
-                </a:solidFill>
-                <a:latin typeface="Be Vietnam Pro" pitchFamily="34" charset="0"/>
-                <a:ea typeface="Be Vietnam Pro" pitchFamily="34" charset="-122"/>
-                <a:cs typeface="Be Vietnam Pro" pitchFamily="34" charset="-120"/>
-              </a:rPr>
-              <a:t>Năm</a:t>
-            </a:r>
-            <a:r>
-              <a:rPr lang="en-US" sz="3000" b="1" dirty="0" spc="-5" kern="0">
-                <a:solidFill>
-                  <a:srgbClr val="14161C"/>
-                </a:solidFill>
-                <a:latin typeface="Be Vietnam Pro" pitchFamily="34" charset="0"/>
-                <a:ea typeface="Be Vietnam Pro" pitchFamily="34" charset="-122"/>
-                <a:cs typeface="Be Vietnam Pro" pitchFamily="34" charset="-120"/>
-              </a:rPr>
-              <a:t> khoản</a:t>
-            </a:r>
-            <a:r>
-              <a:rPr lang="en-US" sz="3000" b="1" dirty="0" spc="6" kern="0">
-                <a:solidFill>
-                  <a:srgbClr val="14161C"/>
-                </a:solidFill>
-                <a:latin typeface="Be Vietnam Pro" pitchFamily="34" charset="0"/>
-                <a:ea typeface="Be Vietnam Pro" pitchFamily="34" charset="-122"/>
-                <a:cs typeface="Be Vietnam Pro" pitchFamily="34" charset="-120"/>
-              </a:rPr>
-              <a:t> đối</a:t>
-            </a:r>
-            <a:r>
-              <a:rPr lang="en-US" sz="3000" b="1" dirty="0" spc="1" kern="0">
-                <a:solidFill>
-                  <a:srgbClr val="14161C"/>
-                </a:solidFill>
-                <a:latin typeface="Be Vietnam Pro" pitchFamily="34" charset="0"/>
-                <a:ea typeface="Be Vietnam Pro" pitchFamily="34" charset="-122"/>
-                <a:cs typeface="Be Vietnam Pro" pitchFamily="34" charset="-120"/>
-              </a:rPr>
-              <a:t> chiếu</a:t>
-            </a:r>
-            <a:r>
-              <a:rPr lang="en-US" sz="3000" b="1" dirty="0" spc="-13" kern="0">
-                <a:solidFill>
-                  <a:srgbClr val="14161C"/>
-                </a:solidFill>
-                <a:latin typeface="Be Vietnam Pro" pitchFamily="34" charset="0"/>
-                <a:ea typeface="Be Vietnam Pro" pitchFamily="34" charset="-122"/>
-                <a:cs typeface="Be Vietnam Pro" pitchFamily="34" charset="-120"/>
-              </a:rPr>
-              <a:t> với</a:t>
-            </a:r>
-            <a:r>
-              <a:rPr lang="en-US" sz="3000" b="1" dirty="0" spc="-2" kern="0">
                 <a:solidFill>
                   <a:srgbClr val="14161C"/>
                 </a:solidFill>

</xml_diff>

<commit_message>
System Design 101 (vi): sd-11-035 slide 7 count and PPTX; note current Elastic IP charging
Co-Authored-By: Claude Sonnet 5.5 <noreply@anthropic.com>
Claude-Session: https://claude.ai/code/session_01MF1cUkoXgxEMeDan8VPPYR
</commit_message>
<xml_diff>
--- a/system-design-101/vi/lessons/sd-11-035/slides/sd-11-035.pptx
+++ b/system-design-101/vi/lessons/sd-11-035/slides/sd-11-035.pptx
@@ -10603,7 +10603,7 @@
               <a:buNone/>
             </a:pPr>
             <a:r>
-              <a:rPr lang="en-US" sz="3300" b="1" dirty="0" spc="-1" kern="0">
+              <a:rPr lang="en-US" sz="3300" b="1" dirty="0" spc="-8" kern="0">
                 <a:solidFill>
                   <a:srgbClr val="F3EEE3"/>
                 </a:solidFill>
@@ -10611,7 +10611,7 @@
                 <a:ea typeface="Be Vietnam Pro" pitchFamily="34" charset="-122"/>
                 <a:cs typeface="Be Vietnam Pro" pitchFamily="34" charset="-120"/>
               </a:rPr>
-              <a:t>Ba</a:t>
+              <a:t>Bốn</a:t>
             </a:r>
             <a:r>
               <a:rPr lang="en-US" sz="3300" b="1" dirty="0" spc="-6" kern="0">

</xml_diff>

<commit_message>
System Design 101 (vi): sd-11-035 deck slide 3 reflects current public IP charging
Co-Authored-By: Claude Sonnet 5.5 <noreply@anthropic.com>
Claude-Session: https://claude.ai/code/session_01MF1cUkoXgxEMeDan8VPPYR
</commit_message>
<xml_diff>
--- a/system-design-101/vi/lessons/sd-11-035/slides/sd-11-035.pptx
+++ b/system-design-101/vi/lessons/sd-11-035/slides/sd-11-035.pptx
@@ -5767,26 +5767,59 @@
               <a:t> IP</a:t>
             </a:r>
             <a:r>
-              <a:rPr lang="en-US" sz="2700" b="1" dirty="0" spc="0" kern="0">
-                <a:solidFill>
-                  <a:srgbClr val="14161C"/>
-                </a:solidFill>
-                <a:latin typeface="Be Vietnam Pro" pitchFamily="34" charset="0"/>
-                <a:ea typeface="Be Vietnam Pro" pitchFamily="34" charset="-122"/>
-                <a:cs typeface="Be Vietnam Pro" pitchFamily="34" charset="-120"/>
-              </a:rPr>
-              <a:t> nhàn</a:t>
-            </a:r>
-            <a:r>
-              <a:rPr lang="en-US" sz="2700" b="1" dirty="0" spc="-13" kern="0">
-                <a:solidFill>
-                  <a:srgbClr val="14161C"/>
-                </a:solidFill>
-                <a:latin typeface="Be Vietnam Pro" pitchFamily="34" charset="0"/>
-                <a:ea typeface="Be Vietnam Pro" pitchFamily="34" charset="-122"/>
-                <a:cs typeface="Be Vietnam Pro" pitchFamily="34" charset="-120"/>
-              </a:rPr>
-              <a:t> rỗi.</a:t>
+              <a:rPr lang="en-US" sz="2700" b="1" dirty="0" spc="-9" kern="0">
+                <a:solidFill>
+                  <a:srgbClr val="14161C"/>
+                </a:solidFill>
+                <a:latin typeface="Be Vietnam Pro" pitchFamily="34" charset="0"/>
+                <a:ea typeface="Be Vietnam Pro" pitchFamily="34" charset="-122"/>
+                <a:cs typeface="Be Vietnam Pro" pitchFamily="34" charset="-120"/>
+              </a:rPr>
+              <a:t> công cộng,</a:t>
+            </a:r>
+            <a:r>
+              <a:rPr lang="en-US" sz="2700" b="1" dirty="0" spc="-6" kern="0">
+                <a:solidFill>
+                  <a:srgbClr val="14161C"/>
+                </a:solidFill>
+                <a:latin typeface="Be Vietnam Pro" pitchFamily="34" charset="0"/>
+                <a:ea typeface="Be Vietnam Pro" pitchFamily="34" charset="-122"/>
+                <a:cs typeface="Be Vietnam Pro" pitchFamily="34" charset="-120"/>
+              </a:rPr>
+              <a:t> cả</a:t>
+            </a:r>
+            <a:r>
+              <a:rPr lang="en-US" sz="2700" b="1" dirty="0" spc="1" kern="0">
+                <a:solidFill>
+                  <a:srgbClr val="14161C"/>
+                </a:solidFill>
+                <a:latin typeface="Be Vietnam Pro" pitchFamily="34" charset="0"/>
+                <a:ea typeface="Be Vietnam Pro" pitchFamily="34" charset="-122"/>
+                <a:cs typeface="Be Vietnam Pro" pitchFamily="34" charset="-120"/>
+              </a:rPr>
+              <a:t> khi</a:t>
+            </a:r>
+            <a:r>
+              <a:rPr lang="en-US" sz="2700" b="1" dirty="0" spc="3" kern="0">
+                <a:solidFill>
+                  <a:srgbClr val="14161C"/>
+                </a:solidFill>
+                <a:latin typeface="Be Vietnam Pro" pitchFamily="34" charset="0"/>
+                <a:ea typeface="Be Vietnam Pro" pitchFamily="34" charset="-122"/>
+                <a:cs typeface="Be Vietnam Pro" pitchFamily="34" charset="-120"/>
+              </a:rPr>
+              <a:t> đang</a:t>
+            </a:r>
+            <a:r>
+              <a:rPr lang="en-US" sz="2700" b="1" dirty="0" spc="-1" kern="0">
+                <a:solidFill>
+                  <a:srgbClr val="14161C"/>
+                </a:solidFill>
+                <a:latin typeface="Be Vietnam Pro" pitchFamily="34" charset="0"/>
+                <a:ea typeface="Be Vietnam Pro" pitchFamily="34" charset="-122"/>
+                <a:cs typeface="Be Vietnam Pro" pitchFamily="34" charset="-120"/>
+              </a:rPr>
+              <a:t> gắn.</a:t>
             </a:r>
             <a:endParaRPr lang="en-US" sz="2700" dirty="0"/>
           </a:p>

</xml_diff>

<commit_message>
System Design 101 (vi): sd-11-037 cover lever label, sd-11-035 deck sources include current VPC pricing
Co-Authored-By: Claude Sonnet 5.5 <noreply@anthropic.com>
Claude-Session: https://claude.ai/code/session_01MF1cUkoXgxEMeDan8VPPYR
</commit_message>
<xml_diff>
--- a/system-design-101/vi/lessons/sd-11-035/slides/sd-11-035.pptx
+++ b/system-design-101/vi/lessons/sd-11-035/slides/sd-11-035.pptx
@@ -3534,7 +3534,7 @@
       </p:sp>
       <p:sp>
         <p:nvSpPr>
-          <p:cNvPr id="13" name="Text richtext-1792420815217-724133264"/>
+          <p:cNvPr id="13" name="Text 11"/>
           <p:cNvSpPr/>
           <p:nvPr/>
         </p:nvSpPr>
@@ -3553,16 +3553,14 @@
           <a:bodyPr wrap="square" lIns="0" tIns="5334" rIns="0" bIns="-5334" rtlCol="0" anchor="t"/>
           <a:lstStyle/>
           <a:p>
-            <a:pPr algn="l" marL="304800" indent="-217761">
+            <a:pPr algn="l" indent="0" marL="0">
               <a:lnSpc>
                 <a:spcPts val="3360"/>
               </a:lnSpc>
               <a:spcAft>
                 <a:spcPts val="1350"/>
               </a:spcAft>
-              <a:buSzPct val="100000"/>
-              <a:buFont typeface="Arial"/>
-              <a:buChar char="•"/>
+              <a:buNone/>
             </a:pPr>
             <a:r>
               <a:rPr lang="en-US" sz="2400" dirty="0" spc="-2" kern="0">
@@ -3644,16 +3642,14 @@
             <a:endParaRPr lang="en-US" sz="2400" dirty="0"/>
           </a:p>
           <a:p>
-            <a:pPr algn="l" marL="304800" indent="-217761">
+            <a:pPr algn="l" indent="0" marL="0">
               <a:lnSpc>
                 <a:spcPts val="3360"/>
               </a:lnSpc>
               <a:spcAft>
                 <a:spcPts val="1350"/>
               </a:spcAft>
-              <a:buSzPct val="100000"/>
-              <a:buFont typeface="Arial"/>
-              <a:buChar char="•"/>
+              <a:buNone/>
             </a:pPr>
             <a:r>
               <a:rPr lang="en-US" sz="2400" dirty="0" spc="-53" kern="0">
@@ -3724,13 +3720,14 @@
             <a:endParaRPr lang="en-US" sz="2400" dirty="0"/>
           </a:p>
           <a:p>
-            <a:pPr algn="l" marL="304800" indent="-217761">
+            <a:pPr algn="l" indent="0" marL="0">
               <a:lnSpc>
                 <a:spcPts val="3360"/>
               </a:lnSpc>
-              <a:buSzPct val="100000"/>
-              <a:buFont typeface="Arial"/>
-              <a:buChar char="•"/>
+              <a:spcAft>
+                <a:spcPts val="1350"/>
+              </a:spcAft>
+              <a:buNone/>
             </a:pPr>
             <a:r>
               <a:rPr lang="en-US" sz="2400" dirty="0" spc="-53" kern="0">
@@ -3788,7 +3785,7 @@
               <a:t> lưu</a:t>
             </a:r>
             <a:r>
-              <a:rPr lang="en-US" sz="2400" dirty="0" spc="41" kern="0">
+              <a:rPr lang="en-US" sz="2400" dirty="0" spc="3" kern="0">
                 <a:solidFill>
                   <a:srgbClr val="F3EEE3"/>
                 </a:solidFill>
@@ -3796,7 +3793,137 @@
                 <a:ea typeface="Be Vietnam Pro" pitchFamily="34" charset="-122"/>
                 <a:cs typeface="Be Vietnam Pro" pitchFamily="34" charset="-120"/>
               </a:rPr>
-              <a:t> trữ)</a:t>
+              <a:t> trữ,</a:t>
+            </a:r>
+            <a:r>
+              <a:rPr lang="en-US" sz="2400" dirty="0" spc="18" kern="0">
+                <a:solidFill>
+                  <a:srgbClr val="F3EEE3"/>
+                </a:solidFill>
+                <a:latin typeface="Be Vietnam Pro" pitchFamily="34" charset="0"/>
+                <a:ea typeface="Be Vietnam Pro" pitchFamily="34" charset="-122"/>
+                <a:cs typeface="Be Vietnam Pro" pitchFamily="34" charset="-120"/>
+              </a:rPr>
+              <a:t> đã</a:t>
+            </a:r>
+            <a:r>
+              <a:rPr lang="en-US" sz="2400" dirty="0" spc="2" kern="0">
+                <a:solidFill>
+                  <a:srgbClr val="F3EEE3"/>
+                </a:solidFill>
+                <a:latin typeface="Be Vietnam Pro" pitchFamily="34" charset="0"/>
+                <a:ea typeface="Be Vietnam Pro" pitchFamily="34" charset="-122"/>
+                <a:cs typeface="Be Vietnam Pro" pitchFamily="34" charset="-120"/>
+              </a:rPr>
+              <a:t> cũ)</a:t>
+            </a:r>
+            <a:endParaRPr lang="en-US" sz="2400" dirty="0"/>
+          </a:p>
+          <a:p>
+            <a:pPr algn="l" indent="0" marL="0">
+              <a:lnSpc>
+                <a:spcPts val="3360"/>
+              </a:lnSpc>
+              <a:buNone/>
+            </a:pPr>
+            <a:r>
+              <a:rPr lang="en-US" sz="2400" dirty="0" spc="-53" kern="0">
+                <a:solidFill>
+                  <a:srgbClr val="F3EEE3"/>
+                </a:solidFill>
+                <a:latin typeface="Be Vietnam Pro" pitchFamily="34" charset="0"/>
+                <a:ea typeface="Be Vietnam Pro" pitchFamily="34" charset="-122"/>
+                <a:cs typeface="Be Vietnam Pro" pitchFamily="34" charset="-120"/>
+              </a:rPr>
+              <a:t>AWS,</a:t>
+            </a:r>
+            <a:r>
+              <a:rPr lang="en-US" sz="2400" dirty="0" spc="-13" kern="0">
+                <a:solidFill>
+                  <a:srgbClr val="F3EEE3"/>
+                </a:solidFill>
+                <a:latin typeface="Be Vietnam Pro" pitchFamily="34" charset="0"/>
+                <a:ea typeface="Be Vietnam Pro" pitchFamily="34" charset="-122"/>
+                <a:cs typeface="Be Vietnam Pro" pitchFamily="34" charset="-120"/>
+              </a:rPr>
+              <a:t> trang</a:t>
+            </a:r>
+            <a:r>
+              <a:rPr lang="en-US" sz="2400" dirty="0" spc="2" kern="0">
+                <a:solidFill>
+                  <a:srgbClr val="F3EEE3"/>
+                </a:solidFill>
+                <a:latin typeface="Be Vietnam Pro" pitchFamily="34" charset="0"/>
+                <a:ea typeface="Be Vietnam Pro" pitchFamily="34" charset="-122"/>
+                <a:cs typeface="Be Vietnam Pro" pitchFamily="34" charset="-120"/>
+              </a:rPr>
+              <a:t> giá</a:t>
+            </a:r>
+            <a:r>
+              <a:rPr lang="en-US" sz="2400" dirty="0" spc="0" kern="0">
+                <a:solidFill>
+                  <a:srgbClr val="F3EEE3"/>
+                </a:solidFill>
+                <a:latin typeface="Be Vietnam Pro" pitchFamily="34" charset="0"/>
+                <a:ea typeface="Be Vietnam Pro" pitchFamily="34" charset="-122"/>
+                <a:cs typeface="Be Vietnam Pro" pitchFamily="34" charset="-120"/>
+              </a:rPr>
+              <a:t> Amazon</a:t>
+            </a:r>
+            <a:r>
+              <a:rPr lang="en-US" sz="2400" dirty="0" spc="-3" kern="0">
+                <a:solidFill>
+                  <a:srgbClr val="F3EEE3"/>
+                </a:solidFill>
+                <a:latin typeface="Be Vietnam Pro" pitchFamily="34" charset="0"/>
+                <a:ea typeface="Be Vietnam Pro" pitchFamily="34" charset="-122"/>
+                <a:cs typeface="Be Vietnam Pro" pitchFamily="34" charset="-120"/>
+              </a:rPr>
+              <a:t> VPC</a:t>
+            </a:r>
+            <a:r>
+              <a:rPr lang="en-US" sz="2400" dirty="0" spc="3" kern="0">
+                <a:solidFill>
+                  <a:srgbClr val="F3EEE3"/>
+                </a:solidFill>
+                <a:latin typeface="Be Vietnam Pro" pitchFamily="34" charset="0"/>
+                <a:ea typeface="Be Vietnam Pro" pitchFamily="34" charset="-122"/>
+                <a:cs typeface="Be Vietnam Pro" pitchFamily="34" charset="-120"/>
+              </a:rPr>
+              <a:t> (giá</a:t>
+            </a:r>
+            <a:r>
+              <a:rPr lang="en-US" sz="2400" dirty="0" spc="-4" kern="0">
+                <a:solidFill>
+                  <a:srgbClr val="F3EEE3"/>
+                </a:solidFill>
+                <a:latin typeface="Be Vietnam Pro" pitchFamily="34" charset="0"/>
+                <a:ea typeface="Be Vietnam Pro" pitchFamily="34" charset="-122"/>
+                <a:cs typeface="Be Vietnam Pro" pitchFamily="34" charset="-120"/>
+              </a:rPr>
+              <a:t> IP</a:t>
+            </a:r>
+            <a:r>
+              <a:rPr lang="en-US" sz="2400" dirty="0" spc="0" kern="0">
+                <a:solidFill>
+                  <a:srgbClr val="F3EEE3"/>
+                </a:solidFill>
+                <a:latin typeface="Be Vietnam Pro" pitchFamily="34" charset="0"/>
+                <a:ea typeface="Be Vietnam Pro" pitchFamily="34" charset="-122"/>
+                <a:cs typeface="Be Vietnam Pro" pitchFamily="34" charset="-120"/>
+              </a:rPr>
+              <a:t> hiện</a:t>
+            </a:r>
+            <a:r>
+              <a:rPr lang="en-US" sz="2400" dirty="0" spc="1" kern="0">
+                <a:solidFill>
+                  <a:srgbClr val="F3EEE3"/>
+                </a:solidFill>
+                <a:latin typeface="Be Vietnam Pro" pitchFamily="34" charset="0"/>
+                <a:ea typeface="Be Vietnam Pro" pitchFamily="34" charset="-122"/>
+                <a:cs typeface="Be Vietnam Pro" pitchFamily="34" charset="-120"/>
+              </a:rPr>
+              <a:t> hành)</a:t>
             </a:r>
             <a:endParaRPr lang="en-US" sz="2400" dirty="0"/>
           </a:p>

</xml_diff>

<commit_message>
System Design 101 (vi): sd-11-035 fold partial uploads into the per-GB row, add current VPC pricing source
Co-Authored-By: Claude Sonnet 5.5 <noreply@anthropic.com>
Claude-Session: https://claude.ai/code/session_01MF1cUkoXgxEMeDan8VPPYR
</commit_message>
<xml_diff>
--- a/system-design-101/vi/lessons/sd-11-035/slides/sd-11-035.pptx
+++ b/system-design-101/vi/lessons/sd-11-035/slides/sd-11-035.pptx
@@ -2571,7 +2571,7 @@
               <a:buNone/>
             </a:pPr>
             <a:r>
-              <a:rPr lang="en-US" sz="2250" b="1" dirty="0" spc="4" kern="0">
+              <a:rPr lang="en-US" sz="2250" b="1" dirty="0" spc="2" kern="0">
                 <a:solidFill>
                   <a:srgbClr val="FFB454"/>
                 </a:solidFill>
@@ -2579,18 +2579,7 @@
                 <a:ea typeface="Be Vietnam Pro" pitchFamily="34" charset="-122"/>
                 <a:cs typeface="Be Vietnam Pro" pitchFamily="34" charset="-120"/>
               </a:rPr>
-              <a:t>Dở</a:t>
-            </a:r>
-            <a:r>
-              <a:rPr lang="en-US" sz="2250" b="1" dirty="0" spc="-2" kern="0">
-                <a:solidFill>
-                  <a:srgbClr val="FFB454"/>
-                </a:solidFill>
-                <a:latin typeface="Be Vietnam Pro" pitchFamily="34" charset="0"/>
-                <a:ea typeface="Be Vietnam Pro" pitchFamily="34" charset="-122"/>
-                <a:cs typeface="Be Vietnam Pro" pitchFamily="34" charset="-120"/>
-              </a:rPr>
-              <a:t> dang,</a:t>
+              <a:t>Dữ liệu</a:t>
             </a:r>
             <a:r>
               <a:rPr lang="en-US" sz="2250" b="1" dirty="0" spc="24" kern="0">

</xml_diff>